<commit_message>
docs(submission-templates): move screenshot notes into titles
</commit_message>
<xml_diff>
--- a/labs/070-lab-process-explorer/assets/Process Explorer SUBMISSION TEMPLATE.pptx
+++ b/labs/070-lab-process-explorer/assets/Process Explorer SUBMISSION TEMPLATE.pptx
@@ -7057,7 +7057,8 @@
           <a:lstStyle/>
           <a:p>
             <a:r>
-              <a:t>Screenshot 9</a:t>
+              <a:rPr sz="1800"/>
+              <a:t>Screenshot 9 Security tab under the limited account showing the owner and reduced privileges.</a:t>
             </a:r>
           </a:p>
         </p:txBody>
@@ -7076,11 +7077,7 @@
         <p:txBody>
           <a:bodyPr/>
           <a:lstStyle/>
-          <a:p>
-            <a:r>
-              <a:t>Security tab under the limited account showing the owner and reduced privileges.</a:t>
-            </a:r>
-          </a:p>
+          <a:p/>
         </p:txBody>
       </p:sp>
     </p:spTree>
@@ -7132,7 +7129,8 @@
           <a:lstStyle/>
           <a:p>
             <a:r>
-              <a:t>Screenshot 1</a:t>
+              <a:rPr sz="2000"/>
+              <a:t>Screenshot 1 Security tab showing the Groups and Privileges panels for cmd.exe.</a:t>
             </a:r>
           </a:p>
         </p:txBody>
@@ -7159,11 +7157,7 @@
             <a:normAutofit/>
           </a:bodyPr>
           <a:lstStyle/>
-          <a:p>
-            <a:r>
-              <a:t>Security tab showing the Groups and Privileges panels for cmd.exe.</a:t>
-            </a:r>
-          </a:p>
+          <a:p/>
         </p:txBody>
       </p:sp>
     </p:spTree>
@@ -7215,7 +7209,8 @@
           <a:lstStyle/>
           <a:p>
             <a:r>
-              <a:t>Screenshot 2</a:t>
+              <a:rPr sz="2200"/>
+              <a:t>Screenshot 2 Display showing the DLLs loaded by cmd.exe.</a:t>
             </a:r>
           </a:p>
         </p:txBody>
@@ -7242,11 +7237,7 @@
             <a:normAutofit/>
           </a:bodyPr>
           <a:lstStyle/>
-          <a:p>
-            <a:r>
-              <a:t>Display showing the DLLs loaded by cmd.exe.</a:t>
-            </a:r>
-          </a:p>
+          <a:p/>
         </p:txBody>
       </p:sp>
     </p:spTree>
@@ -7298,7 +7289,8 @@
           <a:lstStyle/>
           <a:p>
             <a:r>
-              <a:t>Screenshot 3</a:t>
+              <a:rPr sz="1800"/>
+              <a:t>Screenshot 3 TCP/IP tab showing the established ports for the first iexplore.exe process.</a:t>
             </a:r>
           </a:p>
         </p:txBody>
@@ -7325,11 +7317,7 @@
             <a:normAutofit/>
           </a:bodyPr>
           <a:lstStyle/>
-          <a:p>
-            <a:r>
-              <a:t>TCP/IP tab showing the established ports for the first iexplore.exe process.</a:t>
-            </a:r>
-          </a:p>
+          <a:p/>
         </p:txBody>
       </p:sp>
     </p:spTree>
@@ -7381,7 +7369,8 @@
           <a:lstStyle/>
           <a:p>
             <a:r>
-              <a:t>Screenshot 4</a:t>
+              <a:rPr sz="1800"/>
+              <a:t>Screenshot 4 TCP/IP tab showing the IP addresses and ports for the second iexplore.exe process.</a:t>
             </a:r>
           </a:p>
         </p:txBody>
@@ -7408,11 +7397,7 @@
             <a:normAutofit/>
           </a:bodyPr>
           <a:lstStyle/>
-          <a:p>
-            <a:r>
-              <a:t>TCP/IP tab showing the IP addresses and ports for the second iexplore.exe process.</a:t>
-            </a:r>
-          </a:p>
+          <a:p/>
         </p:txBody>
       </p:sp>
     </p:spTree>
@@ -7464,7 +7449,8 @@
           <a:lstStyle/>
           <a:p>
             <a:r>
-              <a:t>Screenshot 5</a:t>
+              <a:rPr sz="2000"/>
+              <a:t>Screenshot 5 Properties TCP/IP display for patch.exe showing the port numbers.</a:t>
             </a:r>
           </a:p>
         </p:txBody>
@@ -7491,11 +7477,7 @@
             <a:normAutofit/>
           </a:bodyPr>
           <a:lstStyle/>
-          <a:p>
-            <a:r>
-              <a:t>Properties TCP/IP display for patch.exe showing the port numbers.</a:t>
-            </a:r>
-          </a:p>
+          <a:p/>
         </p:txBody>
       </p:sp>
     </p:spTree>
@@ -7547,7 +7529,8 @@
           <a:lstStyle/>
           <a:p>
             <a:r>
-              <a:t>Screenshot 6</a:t>
+              <a:rPr sz="2000"/>
+              <a:t>Screenshot 6 Properties TCP/IP display for tini.exe showing the port numbers.</a:t>
             </a:r>
           </a:p>
         </p:txBody>
@@ -7574,11 +7557,7 @@
             <a:normAutofit/>
           </a:bodyPr>
           <a:lstStyle/>
-          <a:p>
-            <a:r>
-              <a:t>Properties TCP/IP display for tini.exe showing the port numbers.</a:t>
-            </a:r>
-          </a:p>
+          <a:p/>
         </p:txBody>
       </p:sp>
     </p:spTree>
@@ -7630,7 +7609,8 @@
           <a:lstStyle/>
           <a:p>
             <a:r>
-              <a:t>Screenshot 7</a:t>
+              <a:rPr sz="2000"/>
+              <a:t>Screenshot 7 Properties Image tab for lsass.exe showing the expected details.</a:t>
             </a:r>
           </a:p>
         </p:txBody>
@@ -7657,11 +7637,7 @@
             <a:normAutofit/>
           </a:bodyPr>
           <a:lstStyle/>
-          <a:p>
-            <a:r>
-              <a:t>Properties Image tab for lsass.exe showing the expected details.</a:t>
-            </a:r>
-          </a:p>
+          <a:p/>
         </p:txBody>
       </p:sp>
     </p:spTree>
@@ -7713,7 +7689,8 @@
           <a:lstStyle/>
           <a:p>
             <a:r>
-              <a:t>Screenshot 8</a:t>
+              <a:rPr sz="2000"/>
+              <a:t>Screenshot 8 Properties Image tab for the fake lsass.exe showing signs of malware.</a:t>
             </a:r>
           </a:p>
         </p:txBody>
@@ -7740,11 +7717,7 @@
             <a:normAutofit/>
           </a:bodyPr>
           <a:lstStyle/>
-          <a:p>
-            <a:r>
-              <a:t>Properties Image tab for the fake lsass.exe showing signs of malware.</a:t>
-            </a:r>
-          </a:p>
+          <a:p/>
         </p:txBody>
       </p:sp>
     </p:spTree>

</xml_diff>